<commit_message>
Make presentation content data-driven, implement weekly scheduler job, fix README links
- Fallback slide deck is now generated from the actual computed portfolio
  metrics instead of hardcoded values, so the PPTX always matches the
  weekly reports (status, scores, SPI, resource gaps, risk matrix).
- Slide 1 stat cards and slide 3 risk heatmap render from computed data.
- weekly_job now actually analyzes all project plans and saves dated reports.
- README: relative deliverable links, scheduler and LLM setup docs.
- Untrack internal planning doc and duplicate root-level xlsx files.
</commit_message>
<xml_diff>
--- a/outputs/monthly_presentation/executive_deck_july_2026.pptx
+++ b/outputs/monthly_presentation/executive_deck_july_2026.pptx
@@ -508,7 +508,7 @@
           <a:lstStyle/>
           <a:p>
             <a:r>
-              <a:t>Good morning team. This slide presents the health of our active S2P implementation portfolio. Both projects are currently in Red status, driven by significant delays in configuration workshops and massive gaps in resource assignments.</a:t>
+              <a:t>This slide summarizes the automated health assessment of the portfolio. Zycus - Titan S2P Implementation is AMBER with a composite health score of 60/100 (71% complete). Zycus - UniSan S2P Implementation is AMBER with a composite health score of 60/100 (44% complete).</a:t>
             </a:r>
           </a:p>
         </p:txBody>
@@ -578,7 +578,7 @@
           <a:lstStyle/>
           <a:p>
             <a:r>
-              <a:t>Looking at the 3-week rolling trends, we see a rapid decline in both projects. This is not a sudden drop but an acceleration of build delays that have gone unmitigated.</a:t>
+              <a:t>Trend view across the reporting weeks. Score erosion is driven primarily by schedule performance and growing critical-path delays, not by task velocity.</a:t>
             </a:r>
           </a:p>
         </p:txBody>
@@ -648,7 +648,7 @@
           <a:lstStyle/>
           <a:p>
             <a:r>
-              <a:t>We have prioritized our risks. The top three are schedule slippages on S2P Phase 2, Hypercare stalls on S2P, and the extensive resource gaps across the board.</a:t>
+              <a:t>Risks are ranked from the weakest computed signals and the largest milestone variances.</a:t>
             </a:r>
           </a:p>
         </p:txBody>
@@ -718,7 +718,7 @@
           <a:lstStyle/>
           <a:p>
             <a:r>
-              <a:t>This slide breaks down the specific schedule offenders. S2P Phase 2 is currently 81 days late against baseline, and Plan B's Training is pushing out critical launch dates.</a:t>
+              <a:t>Detailed schedule breakdown, generated from baseline-versus-actual variance in the project plans.</a:t>
             </a:r>
           </a:p>
         </p:txBody>
@@ -788,7 +788,7 @@
           <a:lstStyle/>
           <a:p>
             <a:r>
-              <a:t>Resource assignment is our biggest bottleneck. With 67% of tasks unassigned in the S2P project, progress has halted. We also have three active blockers on JDE and D&amp;B integrations.</a:t>
+              <a:t>Resource coverage is the portfolio's most consistent weakness; the donut chart shows assigned versus unassigned active tasks.</a:t>
             </a:r>
           </a:p>
         </p:txBody>
@@ -858,7 +858,7 @@
           <a:lstStyle/>
           <a:p>
             <a:r>
-              <a:t>To recover, we must immediately assign resources to critical path tasks, escalate the D&amp;B integration credential blocker today, and adjust our baselines for the remaining S2P phases.</a:t>
+              <a:t>Each recommendation maps directly to a failing or weak signal in the RAG framework.</a:t>
             </a:r>
           </a:p>
         </p:txBody>
@@ -928,7 +928,7 @@
           <a:lstStyle/>
           <a:p>
             <a:r>
-              <a:t>In the next 30 days, we face a critical decision. If we don't allocate resources now, our December Go-Live for Titan will slip into early next year. Intervening now recovers crucial schedule variance.</a:t>
+              <a:t>Projection extrapolates the observed weekly score trend forward four weeks.</a:t>
             </a:r>
           </a:p>
         </p:txBody>
@@ -4023,7 +4023,7 @@
               </a:defRPr>
             </a:pPr>
             <a:r>
-              <a:t>Critical schedule and resource risks impacting S2P implementation timelines</a:t>
+              <a:t>Automated RAG assessment across 2 active implementations (2026-06-18 to 2026-07-02)</a:t>
             </a:r>
           </a:p>
         </p:txBody>
@@ -4062,7 +4062,7 @@
               </a:defRPr>
             </a:pPr>
             <a:r>
-              <a:t>• S2P Project (Titan) is currently RED with composite score of 33/100.</a:t>
+              <a:t>• Zycus - Titan S2P Implementation is AMBER with a composite health score of 60/100 (71% complete).</a:t>
             </a:r>
           </a:p>
           <a:p>
@@ -4078,7 +4078,7 @@
               </a:defRPr>
             </a:pPr>
             <a:r>
-              <a:t>• Project Plan B (UniSan) is currently RED with composite score of 32/100.</a:t>
+              <a:t>• Zycus - UniSan S2P Implementation is AMBER with a composite health score of 60/100 (44% complete).</a:t>
             </a:r>
           </a:p>
           <a:p>
@@ -4094,7 +4094,7 @@
               </a:defRPr>
             </a:pPr>
             <a:r>
-              <a:t>• Both projects suffer from severe resource allocation shortages.</a:t>
+              <a:t>• Resource coverage is the portfolio's weakest signal: 86% of Titan S2P Implementation active tasks are unassigned, 38% of UniSan S2P Implementation active tasks are unassigned.</a:t>
             </a:r>
           </a:p>
           <a:p>
@@ -4110,7 +4110,7 @@
               </a:defRPr>
             </a:pPr>
             <a:r>
-              <a:t>• Active tasks unassigned: S2P (67.5%), Project Plan B (35.4%).</a:t>
+              <a:t>• Combined, 280 active tasks across the portfolio have no owner, led by Zycus - Titan S2P Implementation.</a:t>
             </a:r>
           </a:p>
           <a:p>
@@ -4126,7 +4126,7 @@
               </a:defRPr>
             </a:pPr>
             <a:r>
-              <a:t>• Cascading schedule delays are impacting downstream Hypercare phases.</a:t>
+              <a:t>• Both projects carry schedule slippage on in-flight phases that is compressing downstream UAT and Hypercare windows.</a:t>
             </a:r>
           </a:p>
         </p:txBody>
@@ -4140,7 +4140,7 @@
         <p:spPr>
           <a:xfrm>
             <a:off x="7315200" y="1371600"/>
-            <a:ext cx="4389120" cy="2103120"/>
+            <a:ext cx="4389120" cy="2286000"/>
           </a:xfrm>
           <a:prstGeom prst="roundRect">
             <a:avLst/>
@@ -4173,14 +4173,14 @@
           <a:lstStyle/>
           <a:p>
             <a:pPr algn="ctr">
-              <a:defRPr b="1" sz="1600">
+              <a:defRPr b="1" sz="1500">
                 <a:solidFill>
                   <a:srgbClr val="1B2A4A"/>
                 </a:solidFill>
               </a:defRPr>
             </a:pPr>
             <a:r>
-              <a:t>Project A: S2P Titan Implementation</a:t>
+              <a:t>Zycus - Titan S2P Implementation</a:t>
             </a:r>
           </a:p>
           <a:p>
@@ -4192,7 +4192,7 @@
               </a:defRPr>
             </a:pPr>
             <a:r>
-              <a:t>Overall Status: 🔴 RED</a:t>
+              <a:t>Overall Status: 🟡 AMBER (60/100)</a:t>
             </a:r>
             <a:br/>
             <a:r>
@@ -4200,11 +4200,15 @@
             </a:r>
             <a:br/>
             <a:r>
-              <a:t>Schedule Index (SPI): 0.77</a:t>
+              <a:t>Schedule Index (SPI): 1.25</a:t>
             </a:r>
             <a:br/>
             <a:r>
-              <a:t>Unassigned tasks: 67.5%</a:t>
+              <a:t>Unassigned active tasks: 191 (86%)</a:t>
+            </a:r>
+            <a:br/>
+            <a:r>
+              <a:t>Data confidence: 92%</a:t>
             </a:r>
           </a:p>
         </p:txBody>
@@ -4218,7 +4222,7 @@
         <p:spPr>
           <a:xfrm>
             <a:off x="7315200" y="3840480"/>
-            <a:ext cx="4389120" cy="2103120"/>
+            <a:ext cx="4389120" cy="2286000"/>
           </a:xfrm>
           <a:prstGeom prst="roundRect">
             <a:avLst/>
@@ -4251,14 +4255,14 @@
           <a:lstStyle/>
           <a:p>
             <a:pPr algn="ctr">
-              <a:defRPr b="1" sz="1600">
+              <a:defRPr b="1" sz="1500">
                 <a:solidFill>
                   <a:srgbClr val="1B2A4A"/>
                 </a:solidFill>
               </a:defRPr>
             </a:pPr>
             <a:r>
-              <a:t>Project B: S2P UniSan Implementation</a:t>
+              <a:t>Zycus - UniSan S2P Implementation</a:t>
             </a:r>
           </a:p>
           <a:p>
@@ -4270,7 +4274,7 @@
               </a:defRPr>
             </a:pPr>
             <a:r>
-              <a:t>Overall Status: 🔴 RED</a:t>
+              <a:t>Overall Status: 🟡 AMBER (60/100)</a:t>
             </a:r>
             <a:br/>
             <a:r>
@@ -4278,11 +4282,15 @@
             </a:r>
             <a:br/>
             <a:r>
-              <a:t>Schedule Index (SPI): 0.79</a:t>
+              <a:t>Schedule Index (SPI): 0.75</a:t>
             </a:r>
             <a:br/>
             <a:r>
-              <a:t>Unassigned tasks: 35.4%</a:t>
+              <a:t>Unassigned active tasks: 89 (38%)</a:t>
+            </a:r>
+            <a:br/>
+            <a:r>
+              <a:t>Data confidence: 96%</a:t>
             </a:r>
           </a:p>
         </p:txBody>
@@ -4394,7 +4402,7 @@
               </a:defRPr>
             </a:pPr>
             <a:r>
-              <a:t>Steep decline in health metrics over the past 3 weeks</a:t>
+              <a:t>Composite health score movement across the reporting period</a:t>
             </a:r>
           </a:p>
         </p:txBody>
@@ -4433,7 +4441,7 @@
               </a:defRPr>
             </a:pPr>
             <a:r>
-              <a:t>• S2P Project composite health fell from 52 (Amber) to 33 (Red) in 14 days.</a:t>
+              <a:t>• Zycus - Titan S2P Implementation: composite score moved from 62 to 60 (-2.2 pts) over 2026-06-18 to 2026-07-02 — trajectory STABLE.</a:t>
             </a:r>
           </a:p>
           <a:p>
@@ -4449,7 +4457,7 @@
               </a:defRPr>
             </a:pPr>
             <a:r>
-              <a:t>• Project Plan B health dropped from 48 (Amber) to 32 (Red) in the same period.</a:t>
+              <a:t>• Zycus - UniSan S2P Implementation: composite score moved from 69 to 60 (-8.7 pts) over 2026-06-18 to 2026-07-02 — trajectory DECLINING.</a:t>
             </a:r>
           </a:p>
           <a:p>
@@ -4465,7 +4473,7 @@
               </a:defRPr>
             </a:pPr>
             <a:r>
-              <a:t>• Timeline compression is accelerating in build and configuration phases.</a:t>
+              <a:t>• Portfolio-average health changed -5.4 points over the period; overall trajectory is DECLINING.</a:t>
             </a:r>
           </a:p>
           <a:p>
@@ -4481,23 +4489,7 @@
               </a:defRPr>
             </a:pPr>
             <a:r>
-              <a:t>• Schedule performance index (SPI) for both projects is below 0.80.</a:t>
-            </a:r>
-          </a:p>
-          <a:p>
-            <a:pPr>
-              <a:spcAft>
-                <a:spcPts val="1000"/>
-              </a:spcAft>
-              <a:defRPr sz="1400">
-                <a:solidFill>
-                  <a:srgbClr val="333333"/>
-                </a:solidFill>
-                <a:latin typeface="Calibri"/>
-              </a:defRPr>
-            </a:pPr>
-            <a:r>
-              <a:t>• Trajectory is DECLINING, and urgent executive intervention is required.</a:t>
+              <a:t>• Score erosion is driven primarily by schedule performance and growing critical-path delays, not by task velocity.</a:t>
             </a:r>
           </a:p>
         </p:txBody>
@@ -4633,7 +4625,7 @@
               </a:defRPr>
             </a:pPr>
             <a:r>
-              <a:t>Core schedule, resource, and blocker issues mapped by impact</a:t>
+              <a:t>Top risks ranked by signal severity and milestone slippage</a:t>
             </a:r>
           </a:p>
         </p:txBody>
@@ -4672,7 +4664,7 @@
               </a:defRPr>
             </a:pPr>
             <a:r>
-              <a:t>• Risk 1: S2P Phase 2 P2P schedule delay of 81 days (High Impact / High Likelihood).</a:t>
+              <a:t>• Risk 1: Titan S2P Implementation — Resource Coverage scored 15/100. Resource assignment coverage is 14.0%. 191 of 222 active tasks have no assigned owner.</a:t>
             </a:r>
           </a:p>
           <a:p>
@@ -4688,7 +4680,7 @@
               </a:defRPr>
             </a:pPr>
             <a:r>
-              <a:t>• Risk 2: S2P Hypercare 6% complete with 30-day slip (High Impact / High Likelihood).</a:t>
+              <a:t>• Risk 2: Titan S2P Implementation — Schedule Performance scored 30/100. SPI = 1.25. Project is 71.0% complete vs 56.9% elapsed timeline. Critical schedule slippage of…</a:t>
             </a:r>
           </a:p>
           <a:p>
@@ -4704,7 +4696,7 @@
               </a:defRPr>
             </a:pPr>
             <a:r>
-              <a:t>• Risk 3: S2P Resource Gap (67% active tasks unassigned) (High Impact / High Likelihood).</a:t>
+              <a:t>• Risk 3: Titan S2P Implementation — milestone 'Phase 2 - P2P' is 81 days behind baseline.</a:t>
             </a:r>
           </a:p>
           <a:p>
@@ -4720,7 +4712,7 @@
               </a:defRPr>
             </a:pPr>
             <a:r>
-              <a:t>• Risk 4: Plan B Training Phase I delay of 17 days (Medium Impact / High Likelihood).</a:t>
+              <a:t>• Risk 4: UniSan S2P Implementation — Schedule Performance scored 40/100. SPI = 0.75. Project is 44.0% complete vs 58.8% elapsed timeline. Max schedule slippage is 8…</a:t>
             </a:r>
           </a:p>
           <a:p>
@@ -4736,7 +4728,7 @@
               </a:defRPr>
             </a:pPr>
             <a:r>
-              <a:t>• Risk 5: Plan B Configuration Documentation delay of 13 days (Medium Impact / Medium Likelihood).</a:t>
+              <a:t>• Risk 5: UniSan S2P Implementation — Task Completion Velocity scored 40/100. Task Completion Velocity Ratio: 0.75 (44.0% actual progress vs 58.8% elapsed timeline).</a:t>
             </a:r>
           </a:p>
         </p:txBody>
@@ -4750,7 +4742,7 @@
         <p:spPr>
           <a:xfrm>
             <a:off x="7772400" y="1371600"/>
-            <a:ext cx="3931920" cy="4114800"/>
+            <a:ext cx="3931920" cy="4480560"/>
           </a:xfrm>
           <a:prstGeom prst="rect">
             <a:avLst/>
@@ -4796,7 +4788,7 @@
           <a:p>
             <a:br/>
             <a:pPr>
-              <a:defRPr sz="1100">
+              <a:defRPr sz="1000">
                 <a:solidFill>
                   <a:srgbClr val="333333"/>
                 </a:solidFill>
@@ -4807,15 +4799,15 @@
             </a:r>
             <a:br/>
             <a:r>
-              <a:t>- Phase 2 P2P Schedule Slip (-81d)</a:t>
+              <a:t>- Titan S2P Implementation: Resource Coverage (15/100)</a:t>
             </a:r>
             <a:br/>
             <a:r>
-              <a:t>- S2P Hypercare Stall (6% complete)</a:t>
+              <a:t>- Titan S2P Implementation: Schedule Performance (30/100)</a:t>
             </a:r>
             <a:br/>
             <a:r>
-              <a:t>- Titan Resource Deficit (67.5% missing)</a:t>
+              <a:t>- Titan S2P Implementation: Phase 2 - P2P (-81d)</a:t>
             </a:r>
             <a:br/>
             <a:br/>
@@ -4824,7 +4816,15 @@
             </a:r>
             <a:br/>
             <a:r>
-              <a:t>- Plan B Training Phase I Slip (+17d)</a:t>
+              <a:t>- UniSan S2P Implementation: Schedule Performance (40/100)</a:t>
+            </a:r>
+            <a:br/>
+            <a:r>
+              <a:t>- UniSan S2P Implementation: Task Completion Velocity (40/100)</a:t>
+            </a:r>
+            <a:br/>
+            <a:r>
+              <a:t>- UniSan S2P Implementation: Resource Coverage (40/100)</a:t>
             </a:r>
             <a:br/>
             <a:br/>
@@ -4833,7 +4833,7 @@
             </a:r>
             <a:br/>
             <a:r>
-              <a:t>- Plan B Config Documentation delay</a:t>
+              <a:t>- Titan S2P Implementation: Blocker Density (60/100)</a:t>
             </a:r>
           </a:p>
         </p:txBody>
@@ -4945,7 +4945,7 @@
               </a:defRPr>
             </a:pPr>
             <a:r>
-              <a:t>Detailed look at milestone slippages across key phases</a:t>
+              <a:t>Milestone slippage and schedule signal detail by project</a:t>
             </a:r>
           </a:p>
         </p:txBody>
@@ -4984,7 +4984,7 @@
               </a:defRPr>
             </a:pPr>
             <a:r>
-              <a:t>• S2P build phase is running 32 days behind schedule (98% done but stalled).</a:t>
+              <a:t>• Titan S2P Implementation: schedule signal 30/100 — SPI = 1.25. Project is 71.0% complete vs 56.9% elapsed timeline. Critical schedule slippage of 81 days detected.</a:t>
             </a:r>
           </a:p>
           <a:p>
@@ -5000,7 +5000,7 @@
               </a:defRPr>
             </a:pPr>
             <a:r>
-              <a:t>• S2P Phase 2 P2P is currently 21% complete with -81 days variance.</a:t>
+              <a:t>• Titan S2P Implementation: 'Phase 2 - P2P' running 81 days behind baseline (In Progress).</a:t>
             </a:r>
           </a:p>
           <a:p>
@@ -5016,7 +5016,7 @@
               </a:defRPr>
             </a:pPr>
             <a:r>
-              <a:t>• Plan B Training Phase I is delayed 17 days, causing cascading impacts.</a:t>
+              <a:t>• Titan S2P Implementation: 'P2P Cutover' running 62 days behind baseline (Not Started).</a:t>
             </a:r>
           </a:p>
           <a:p>
@@ -5032,7 +5032,7 @@
               </a:defRPr>
             </a:pPr>
             <a:r>
-              <a:t>• Plan B Hypercare Phase I has a 13-day delay (25% complete).</a:t>
+              <a:t>• UniSan S2P Implementation: schedule signal 40/100 — SPI = 0.75. Project is 44.0% complete vs 58.8% elapsed timeline. Max schedule slippage is 8 days.</a:t>
             </a:r>
           </a:p>
           <a:p>
@@ -5048,7 +5048,7 @@
               </a:defRPr>
             </a:pPr>
             <a:r>
-              <a:t>• Late configuration document approvals are compressing testing cycles.</a:t>
+              <a:t>• UniSan S2P Implementation: 'Zycus - UniSan S2P Implementation' running 8 days behind baseline (In Progress).</a:t>
             </a:r>
           </a:p>
         </p:txBody>
@@ -5160,7 +5160,7 @@
               </a:defRPr>
             </a:pPr>
             <a:r>
-              <a:t>Unassigned active tasks and critical path blocker review</a:t>
+              <a:t>Ownership coverage and critical-path exposure</a:t>
             </a:r>
           </a:p>
         </p:txBody>
@@ -5199,7 +5199,7 @@
               </a:defRPr>
             </a:pPr>
             <a:r>
-              <a:t>• S2P Project: 333 tasks (67%) have no assigned owner.</a:t>
+              <a:t>• Titan S2P Implementation: 191 of 222 active tasks (86%) have no assigned owner; 3 tasks are On Hold.</a:t>
             </a:r>
           </a:p>
           <a:p>
@@ -5215,7 +5215,7 @@
               </a:defRPr>
             </a:pPr>
             <a:r>
-              <a:t>• Project Plan B: 136 tasks (35%) have no assigned owner.</a:t>
+              <a:t>• Titan S2P Implementation: dependency risk 70/100 — Dependency risk: 11 of 15 critical path tasks are delayed. 18 active tasks have low schedule float (&lt;= 3…</a:t>
             </a:r>
           </a:p>
           <a:p>
@@ -5231,7 +5231,7 @@
               </a:defRPr>
             </a:pPr>
             <a:r>
-              <a:t>• S2P has 3 active blockers 'On Hold' related to D&amp;B integrations.</a:t>
+              <a:t>• UniSan S2P Implementation: 89 of 234 active tasks (38%) have no assigned owner; 0 tasks are On Hold.</a:t>
             </a:r>
           </a:p>
           <a:p>
@@ -5247,23 +5247,7 @@
               </a:defRPr>
             </a:pPr>
             <a:r>
-              <a:t>• Critical path tasks delayed due to unassigned integration work.</a:t>
-            </a:r>
-          </a:p>
-          <a:p>
-            <a:pPr>
-              <a:spcAft>
-                <a:spcPts val="1000"/>
-              </a:spcAft>
-              <a:defRPr sz="1400">
-                <a:solidFill>
-                  <a:srgbClr val="333333"/>
-                </a:solidFill>
-                <a:latin typeface="Calibri"/>
-              </a:defRPr>
-            </a:pPr>
-            <a:r>
-              <a:t>• Downstream testing depends on immediate completion of integration mappings.</a:t>
+              <a:t>• UniSan S2P Implementation: dependency risk 70/100 — Dependency risk: 2 of 50 critical path tasks are delayed. 32 active tasks have low schedule float (&lt;= 3…</a:t>
             </a:r>
           </a:p>
         </p:txBody>
@@ -5399,7 +5383,7 @@
               </a:defRPr>
             </a:pPr>
             <a:r>
-              <a:t>Actionable steps to stabilize portfolio health and recover timelines</a:t>
+              <a:t>Actions mapped to the weakest health signals</a:t>
             </a:r>
           </a:p>
         </p:txBody>
@@ -5438,7 +5422,7 @@
               </a:defRPr>
             </a:pPr>
             <a:r>
-              <a:t>• Immediate Action: Assign dedicated owners to critical path tasks (Owner: PMs).</a:t>
+              <a:t>• Assign dedicated owners to all unassigned critical-path tasks within one week (Owner: Project Managers).</a:t>
             </a:r>
           </a:p>
           <a:p>
@@ -5454,7 +5438,7 @@
               </a:defRPr>
             </a:pPr>
             <a:r>
-              <a:t>• Blocker Escalation: Set up priority call to resolve D&amp;B credentials (Owner: Zycus Sponsor).</a:t>
+              <a:t>• Re-baseline milestones with material negative variance and publish a recovery plan (Owner: Delivery Leads).</a:t>
             </a:r>
           </a:p>
           <a:p>
@@ -5470,7 +5454,7 @@
               </a:defRPr>
             </a:pPr>
             <a:r>
-              <a:t>• Timeline Re-baselining: Adjust S2P Phase 2 milestone expectations (Owner: Aftab H.).</a:t>
+              <a:t>• Escalate all 'On Hold' blockers to the executive sponsor for resolution this cycle (Owner: Sponsor).</a:t>
             </a:r>
           </a:p>
           <a:p>
@@ -5486,23 +5470,7 @@
               </a:defRPr>
             </a:pPr>
             <a:r>
-              <a:t>• UAT Mitigation: Pull forward Plan B Phase II configuration validations (Owner: Rajat B.).</a:t>
-            </a:r>
-          </a:p>
-          <a:p>
-            <a:pPr>
-              <a:spcAft>
-                <a:spcPts val="1000"/>
-              </a:spcAft>
-              <a:defRPr sz="1400">
-                <a:solidFill>
-                  <a:srgbClr val="333333"/>
-                </a:solidFill>
-                <a:latin typeface="Calibri"/>
-              </a:defRPr>
-            </a:pPr>
-            <a:r>
-              <a:t>• Governance: Establish weekly cross-project syncs to monitor resource gaps.</a:t>
+              <a:t>• Governance: establish a weekly cross-project health review using this automated report.</a:t>
             </a:r>
           </a:p>
         </p:txBody>
@@ -5614,7 +5582,7 @@
               </a:defRPr>
             </a:pPr>
             <a:r>
-              <a:t>Scenario analysis with and without proposed interventions</a:t>
+              <a:t>Trend-based projection with and without intervention</a:t>
             </a:r>
           </a:p>
         </p:txBody>
@@ -5653,7 +5621,7 @@
               </a:defRPr>
             </a:pPr>
             <a:r>
-              <a:t>• Without Intervention: S2P Phase 2 Go-Live will slip from Dec 2026 to Mar 2027.</a:t>
+              <a:t>• Titan S2P Implementation: at the current trend (-1.1 pts/week), the composite score is projected at ~55/100 in 30 days.</a:t>
             </a:r>
           </a:p>
           <a:p>
@@ -5669,7 +5637,7 @@
               </a:defRPr>
             </a:pPr>
             <a:r>
-              <a:t>• Without Intervention: Plan B Phase II milestones will suffer a 3-week cascade delay.</a:t>
+              <a:t>• UniSan S2P Implementation: at the current trend (-4.3 pts/week), the composite score is projected at ~43/100 in 30 days.</a:t>
             </a:r>
           </a:p>
           <a:p>
@@ -5685,7 +5653,7 @@
               </a:defRPr>
             </a:pPr>
             <a:r>
-              <a:t>• With Intervention: Blocker resolution will recover 10 days of integration timeline.</a:t>
+              <a:t>• With intervention (owner assignment + blocker escalation), resource and blocker signals can recover within two reporting cycles.</a:t>
             </a:r>
           </a:p>
           <a:p>
@@ -5701,23 +5669,7 @@
               </a:defRPr>
             </a:pPr>
             <a:r>
-              <a:t>• With Intervention: Resource allocation will stabilize S2P build progress.</a:t>
-            </a:r>
-          </a:p>
-          <a:p>
-            <a:pPr>
-              <a:spcAft>
-                <a:spcPts val="1000"/>
-              </a:spcAft>
-              <a:defRPr sz="1400">
-                <a:solidFill>
-                  <a:srgbClr val="333333"/>
-                </a:solidFill>
-                <a:latin typeface="Calibri"/>
-              </a:defRPr>
-            </a:pPr>
-            <a:r>
-              <a:t>• Milestone Decision: Lock resource assignments by July 15.</a:t>
+              <a:t>• Decision required: lock resource assignments and approve re-baselined milestones at the next steering committee.</a:t>
             </a:r>
           </a:p>
         </p:txBody>

</xml_diff>